<commit_message>
docs: clarify Olist presenter notes with everyday explanations
</commit_message>
<xml_diff>
--- a/presentations/Assignment_I_Olist_2702751284.pptx
+++ b/presentations/Assignment_I_Olist_2702751284.pptx
@@ -202,7 +202,7 @@
           <a:p>
             <a:fld id="{0600A3F7-9C9B-4365-BF1C-04E274B9F51D}" type="datetimeFigureOut">
               <a:rPr lang="en-ID" smtClean="0"/>
-              <a:t>28/09/2026</a:t>
+              <a:t>29/09/2026</a:t>
             </a:fld>
             <a:endParaRPr lang="en-ID"/>
           </a:p>
@@ -516,8 +516,16 @@
           <a:p>
             <a:r>
               <a:rPr lang="en-ID"/>
-              <a:t>Halo, saya Yanlis Alim Sang Putra Lase. Di presentasi ini, saya membahas proyek analitik keterlambatan pengiriman Olist.
-Fokusnya adalah memahami masalah bisnis, menyiapkan data yang bisa dipercaya, lalu merancang analisis yang sesuai. Saya juga akan menjelaskan teknologi yang saya gunakan dan hasil pemeriksaan proyek yang sudah saya jalankan.</a:t>
+              <a:t>Halo, saya Yanlis Alim Sang Putra Lase. Kali ini saya akan menjelaskan proyek analitik keterlambatan pengiriman menggunakan data Olist.</a:t>
+            </a:r>
+          </a:p>
+          <a:p>
+            <a:endParaRPr lang="en-ID"/>
+          </a:p>
+          <a:p>
+            <a:r>
+              <a:rPr lang="en-ID"/>
+              <a:t>Alurnya dimulai dari masalah yang ingin saya pahami, cara saya menyiapkan datanya, lalu hasil analisisnya. Jadi, selain menunjukkan angka, saya juga akan menjelaskan kenapa saya memilih cara kerja dan teknologi tersebut.</a:t>
             </a:r>
           </a:p>
           <a:p>
@@ -547,7 +555,7 @@
           <a:p>
             <a:r>
               <a:rPr lang="en-ID"/>
-              <a:t>Target waktu: 00:00–00:20</a:t>
+              <a:t>Target waktu: 00:00–00:25</a:t>
             </a:r>
           </a:p>
         </p:txBody>
@@ -634,11 +642,34 @@
           <a:p>
             <a:r>
               <a:rPr lang="en-ID"/>
-              <a:t>Untuk graf, node mewakili state, sedangkan edge mewakili hubungan asal seller dengan tujuan customer. Hasilnya adalah 27 node dan 409 rute.
-Demo yang saya jalankan menghasilkan PASS karena jumlah order pada rute sesuai dengan total populasi graf. Delay nasional tetap 8,11 persen.
-Salah satu rute yang perlu diprioritaskan adalah SP ke RJ, dengan 8.158 order dan delay 15,49 persen. Nilainya lebih tinggi dari baseline nasional, sehingga layak diinvestigasi.
-Namun, graf ini tidak mencatat perjalanan transit paket. Saya belum bisa memakai hasil ini untuk menentukan lokasi hub atau menyatakan penyebab fisik bottleneck.
-Analisis lanjutan memerlukan data operasional pengiriman yang lebih rinci.</a:t>
+              <a:t>Untuk graf, saya melihat hubungan antar-state, yaitu wilayah asal seller dan wilayah tujuan customer. Node mewakili state, sedangkan edge mewakili rute asal ke tujuan. Dari data ini terbentuk 27 node dan 409 rute.</a:t>
+            </a:r>
+          </a:p>
+          <a:p>
+            <a:endParaRPr lang="en-ID"/>
+          </a:p>
+          <a:p>
+            <a:r>
+              <a:rPr lang="en-ID"/>
+              <a:t>Hasil pemeriksaan PASS karena jumlah order dari seluruh rute cocok dengan populasi graf. Sebagai contoh, rute SP ke RJ mempunyai 8.158 order dengan delay 15,49 persen. Angka itu lebih tinggi dari delay nasional, yaitu 8,11 persen.</a:t>
+            </a:r>
+          </a:p>
+          <a:p>
+            <a:endParaRPr lang="en-ID"/>
+          </a:p>
+          <a:p>
+            <a:r>
+              <a:rPr lang="en-ID"/>
+              <a:t>Karena volumenya cukup besar dan persentase terlambatnya tinggi, rute ini masuk prioritas investigasi. Namun, kita baru mengetahui asal dan tujuan. Kita belum mengetahui tempat transit atau proses yang menyebabkan keterlambatan.</a:t>
+            </a:r>
+          </a:p>
+          <a:p>
+            <a:endParaRPr lang="en-ID"/>
+          </a:p>
+          <a:p>
+            <a:r>
+              <a:rPr lang="en-ID"/>
+              <a:t>Jadi, graf ini membantu menentukan rute yang perlu diperiksa lebih lanjut. Untuk menentukan lokasi hub atau penyebab fisik masalah, saya masih membutuhkan data operasional yang lebih rinci.</a:t>
             </a:r>
           </a:p>
           <a:p>
@@ -668,7 +699,7 @@
           <a:p>
             <a:r>
               <a:rPr lang="en-ID"/>
-              <a:t>Target waktu: 07:30–08:25</a:t>
+              <a:t>Target waktu: 07:55–08:50</a:t>
             </a:r>
           </a:p>
         </p:txBody>
@@ -755,10 +786,34 @@
           <a:p>
             <a:r>
               <a:rPr lang="en-ID"/>
-              <a:t>Dari hasil tadi, ketiga bagian pemeriksaan demo sudah berhasil. Ingestion konsisten, pemilihan ambang dan evaluasi model cocok, lalu jumlah populasi graf juga sesuai.
-Hasil ini saya tampilkan langsung di PowerPoint sebagai hasil pemeriksaan yang sudah dijalankan, bukan eksekusi live saat presentasi. Kesimpulan proyek ini adalah kita sudah mempunyai baseline, pipeline data bertipe, dan rancangan solusi yang dapat diaudit.
-Langkah berikutnya adalah menguji model pada periode waktu berbeda, menghitung biaya intervensi, dan menilai kebutuhan dashboard bersama pengguna. Dengan begitu, analisis bisa berkembang menjadi keputusan operasional yang lebih terukur.
-Sekian presentasi saya. Terima kasih.</a:t>
+              <a:t>Dari seluruh proses tadi, ketiga pemeriksaan sudah berhasil: ingestion, model, dan graf. PASS di sini berarti hasil yang diperiksa konsisten, bukan berarti masalah keterlambatan sudah selesai.</a:t>
+            </a:r>
+          </a:p>
+          <a:p>
+            <a:endParaRPr lang="en-ID"/>
+          </a:p>
+          <a:p>
+            <a:r>
+              <a:rPr lang="en-ID"/>
+              <a:t>Hasil demo saya tampilkan sebagai pemeriksaan yang sudah dijalankan sebelumnya. Jadi, presentasi ini bisa dijelaskan sepenuhnya lewat PowerPoint.</a:t>
+            </a:r>
+          </a:p>
+          <a:p>
+            <a:endParaRPr lang="en-ID"/>
+          </a:p>
+          <a:p>
+            <a:r>
+              <a:rPr lang="en-ID"/>
+              <a:t>Kesimpulannya, proyek ini sudah menyediakan baseline, data bertipe yang bisa diaudit, dan rancangan analisis untuk meninjau risiko keterlambatan. Berikutnya, model perlu diuji pada periode berbeda dan dibandingkan dengan biaya intervensi. Kebutuhan dashboard juga perlu dibahas bersama pengguna.</a:t>
+            </a:r>
+          </a:p>
+          <a:p>
+            <a:endParaRPr lang="en-ID"/>
+          </a:p>
+          <a:p>
+            <a:r>
+              <a:rPr lang="en-ID"/>
+              <a:t>Dengan langkah itu, analisis bisa berkembang menjadi keputusan yang manfaatnya dapat diukur. Terima kasih.</a:t>
             </a:r>
           </a:p>
           <a:p>
@@ -788,7 +843,7 @@
           <a:p>
             <a:r>
               <a:rPr lang="en-ID"/>
-              <a:t>Target waktu: 08:25–09:10</a:t>
+              <a:t>Target waktu: 08:50–09:30</a:t>
             </a:r>
           </a:p>
         </p:txBody>
@@ -875,11 +930,34 @@
           <a:p>
             <a:r>
               <a:rPr lang="en-ID"/>
-              <a:t>Olist adalah dataset transaksi e-commerce Brasil. Datanya tersebar di sembilan tabel, mulai dari order, customer, seller, sampai item, payment, dan review.
-Masalah yang saya angkat adalah keterlambatan pengiriman. Dari 96.470 order yang tanggal labelnya valid, 7.826 terlambat, atau sekitar 8,11 persen.
-Saya membandingkan waktu penerimaan aktual dengan waktu estimasi. Rata-rata review kelompok tepat waktu sekitar 4,29, sedangkan kelompok terlambat sekitar 2,57.
-Jadi, ada hubungan yang perlu diperhatikan. Namun, angka ini belum membuktikan bahwa keterlambatan adalah satu-satunya penyebab review rendah.
-Itulah alasan saya mulai dari baseline dan kualitas data sebelum membahas tindakan operasional.</a:t>
+              <a:t>Saya mulai dari datanya dulu. Olist merupakan data transaksi e-commerce di Brasil, dengan periode transaksi tahun 2016 sampai 2018. Informasinya tersebar di sembilan tabel. Misalnya, data pesanan ada di tabel order, rincian barang ada di tabel item, dan penilaian pelanggan ada di tabel review.</a:t>
+            </a:r>
+          </a:p>
+          <a:p>
+            <a:endParaRPr lang="en-ID"/>
+          </a:p>
+          <a:p>
+            <a:r>
+              <a:rPr lang="en-ID"/>
+              <a:t>Masalah yang saya fokuskan adalah pengiriman terlambat. Di sini, terlambat berarti waktu penerimaan aktual melewati waktu estimasi. Jadi, saya memakai perbandingan timestamp, bukan sekadar selisih hari.</a:t>
+            </a:r>
+          </a:p>
+          <a:p>
+            <a:endParaRPr lang="en-ID"/>
+          </a:p>
+          <a:p>
+            <a:r>
+              <a:rPr lang="en-ID"/>
+              <a:t>Dari sekitar 96 ribu order dengan tanggal yang valid, ada 7.826 order terlambat, atau 8,11 persen. Rata-rata review kelompok tepat waktu sekitar 4,29, sedangkan kelompok terlambat sekitar 2,57.</a:t>
+            </a:r>
+          </a:p>
+          <a:p>
+            <a:endParaRPr lang="en-ID"/>
+          </a:p>
+          <a:p>
+            <a:r>
+              <a:rPr lang="en-ID"/>
+              <a:t>Angka ini menjadi titik awal atau baseline saya. Ada hubungan yang perlu diperhatikan, tetapi belum bisa disimpulkan bahwa keterlambatan merupakan satu-satunya penyebab review rendah.</a:t>
             </a:r>
           </a:p>
           <a:p>
@@ -909,7 +987,7 @@
           <a:p>
             <a:r>
               <a:rPr lang="en-ID"/>
-              <a:t>Target waktu: 00:20–01:10</a:t>
+              <a:t>Target waktu: 00:25–01:20</a:t>
             </a:r>
           </a:p>
         </p:txBody>
@@ -996,11 +1074,25 @@
           <a:p>
             <a:r>
               <a:rPr lang="en-ID"/>
-              <a:t>Yang ingin saya selesaikan adalah bagaimana mengubah data transaksi yang terpisah menjadi informasi yang bisa dipakai untuk meninjau risiko keterlambatan. Ada dua tujuan utama: menyiapkan pipeline yang konsisten dan membantu menentukan prioritas investigasi.
-Tim Logistics dapat melihat rute yang perlu diperiksa. Merchant Performance dapat meninjau order berisiko setelah approval.
-Manajemen dapat memantau hasil agregat. Untuk Assignment I, pekerjaan utamanya adalah rancangan solusi dan persiapan data.
-Model dan graf saya gunakan sebagai eksplorasi awal. Jadi, saya belum mengatakan keterlambatan sudah turun atau biaya sudah hemat.
-Dampak itu baru bisa diukur setelah ada intervensi.</a:t>
+              <a:t>Dari masalah tadi, saya ingin membuat data transaksi ini lebih mudah dipakai untuk meninjau keterlambatan. Jadi, pekerjaan saya bukan berhenti pada menghitung berapa order yang terlambat, tetapi juga menyiapkan dasar untuk menentukan bagian mana yang perlu diperiksa.</a:t>
+            </a:r>
+          </a:p>
+          <a:p>
+            <a:endParaRPr lang="en-ID"/>
+          </a:p>
+          <a:p>
+            <a:r>
+              <a:rPr lang="en-ID"/>
+              <a:t>Contohnya, tim Logistics bisa melihat rute dengan keterlambatan tinggi. Tim Merchant Performance bisa meninjau order yang ditandai berisiko setelah approval. Sementara itu, manajemen bisa memakai ringkasan hasil untuk memantau kondisi keseluruhan.</a:t>
+            </a:r>
+          </a:p>
+          <a:p>
+            <a:endParaRPr lang="en-ID"/>
+          </a:p>
+          <a:p>
+            <a:r>
+              <a:rPr lang="en-ID"/>
+              <a:t>Untuk Assignment I, fokus utamanya adalah rancangan solusi dan persiapan data. Model dan graf menjadi eksplorasi tambahan. Jadi, hasil saat ini membantu menyusun prioritas investigasi. Penurunan keterlambatan yang sebenarnya baru bisa dibuktikan setelah ada tindakan dan evaluasi dampaknya.</a:t>
             </a:r>
           </a:p>
           <a:p>
@@ -1030,7 +1122,7 @@
           <a:p>
             <a:r>
               <a:rPr lang="en-ID"/>
-              <a:t>Target waktu: 01:10–01:55</a:t>
+              <a:t>Target waktu: 01:20–02:05</a:t>
             </a:r>
           </a:p>
         </p:txBody>
@@ -1117,9 +1209,25 @@
           <a:p>
             <a:r>
               <a:rPr lang="en-ID"/>
-              <a:t>Masalah ini juga relevan dengan konteks e-commerce yang lebih luas. Dalam survei DHL tahun 2026, dua puluh persen pembeli menyatakan pengiriman lebih cepat dapat mendorong penyelesaian pembelian.
-OECD juga membahas peran ulasan dan rating dalam membangun kepercayaan pada platform. Saya memakai sumber ini untuk menjelaskan relevansi masalah, bukan untuk menyimpulkan perilaku pelanggan Olist.
-Survei global tahun 2026 berbeda dari transaksi Olist tahun 2016 sampai 2018. Karena itu, keputusan analitik dalam proyek ini tetap berangkat dari baseline Olist yang saya hitung.</a:t>
+              <a:t>Lalu, kenapa masalah pengiriman ini penting? Dalam e-commerce, pelanggan bukan hanya mempertimbangkan barangnya, tetapi juga kapan barang itu sampai.</a:t>
+            </a:r>
+          </a:p>
+          <a:p>
+            <a:endParaRPr lang="en-ID"/>
+          </a:p>
+          <a:p>
+            <a:r>
+              <a:rPr lang="en-ID"/>
+              <a:t>Sebagai konteks, survei DHL tahun 2026 menyebut dua puluh persen pembeli merasa pengiriman lebih cepat dapat mendorong mereka menyelesaikan pembelian. OECD juga membahas peran ulasan dan rating dalam kepercayaan pada platform.</a:t>
+            </a:r>
+          </a:p>
+          <a:p>
+            <a:endParaRPr lang="en-ID"/>
+          </a:p>
+          <a:p>
+            <a:r>
+              <a:rPr lang="en-ID"/>
+              <a:t>Saya memakai sumber ini untuk menjelaskan relevansi masalah. Namun, survei tersebut berbeda dari data Olist yang saya olah. Jadi, sumber eksternal memberi konteks, sedangkan angka dan prioritas analisis tetap saya ambil dari data proyek.</a:t>
             </a:r>
           </a:p>
           <a:p>
@@ -1150,7 +1258,7 @@
           <a:p>
             <a:r>
               <a:rPr lang="en-ID"/>
-              <a:t>Target waktu: 01:55–02:30</a:t>
+              <a:t>Target waktu: 02:05–02:40</a:t>
             </a:r>
           </a:p>
         </p:txBody>
@@ -1237,12 +1345,43 @@
           <a:p>
             <a:r>
               <a:rPr lang="en-ID"/>
-              <a:t>Untuk pengembangannya, saya memakai Python 3.11, VS Code, dan Jupyter Notebook. Python menjadi bahasa utama, VS Code sebagai editor, dan notebook membantu saya menjelaskan proses sekaligus menyimpan output tiap langkah.
-Pengolahan tabel memakai PySpark 4.0.4, dengan Java 17 sebagai runtime Spark. Saya memilih Spark untuk belajar dan menyatukan transformasi serta MLlib dalam satu framework.
-Dengan data sekitar 120 MiB, pandas sebenarnya masih layak. Jadi, ini bukan klaim bahwa dataset kecil harus memakai cluster.
-Parquet dengan Snappy menyimpan tabel bertipe secara lebih ringkas. MLlib menyediakan Random Forest untuk eksplorasi prediksi.
-NumPy dan SciPy membantu perhitungan numerik untuk evaluasi. Untuk graf, saya memakai pandas dan NetworkX karena jaringan state masih kecil dan bisa dianalisis dalam memori.
-Terakhir, Git dan GitHub menyimpan kode, laporan, serta ringkasan hasil supaya pekerjaan dapat dilanjutkan lintas perangkat. Raw data dan runtime tetap lokal.</a:t>
+              <a:t>Untuk mengerjakan proyek ini, saya memakai Python, dengan VS Code sebagai editor. Jupyter Notebook membantu saya menyusun proses per langkah, sehingga kode dan hasilnya bisa dilihat bersama.</a:t>
+            </a:r>
+          </a:p>
+          <a:p>
+            <a:endParaRPr lang="en-ID"/>
+          </a:p>
+          <a:p>
+            <a:r>
+              <a:rPr lang="en-ID"/>
+              <a:t>Pengolahan tabel menggunakan PySpark. Java 17 dibutuhkan agar Spark dapat berjalan. Alasan saya memakai Spark adalah pembelajaran sekaligus menyatukan pengolahan data dan model dalam satu framework. Untuk ukuran data sekitar 120 MiB, pandas sebenarnya masih cukup. Spark saya jalankan di satu komputer, jadi skalabilitas cluster belum saya uji.</a:t>
+            </a:r>
+          </a:p>
+          <a:p>
+            <a:endParaRPr lang="en-ID"/>
+          </a:p>
+          <a:p>
+            <a:r>
+              <a:rPr lang="en-ID"/>
+              <a:t>Hasil tabel disimpan sebagai Parquet dengan kompresi Snappy. Parquet menyimpan data per kolom dan mempertahankan tipe data, sedangkan Snappy membantu mengecilkan ukuran file.</a:t>
+            </a:r>
+          </a:p>
+          <a:p>
+            <a:endParaRPr lang="en-ID"/>
+          </a:p>
+          <a:p>
+            <a:r>
+              <a:rPr lang="en-ID"/>
+              <a:t>Untuk model, saya memakai Random Forest dari MLlib, yaitu gabungan banyak pohon keputusan. Untuk graf, saya memakai pandas dan NetworkX karena jaringan state ini masih kecil. NumPy dan SciPy membantu perhitungan evaluasi numerik.</a:t>
+            </a:r>
+          </a:p>
+          <a:p>
+            <a:endParaRPr lang="en-ID"/>
+          </a:p>
+          <a:p>
+            <a:r>
+              <a:rPr lang="en-ID"/>
+              <a:t>Git dan GitHub mencatat versi kode, laporan, serta ringkasan hasil. Jadi, kalau melanjutkan pekerjaan di perangkat lain, saya punya versi proyek yang jelas.</a:t>
             </a:r>
           </a:p>
           <a:p>
@@ -1272,7 +1411,7 @@
           <a:p>
             <a:r>
               <a:rPr lang="en-ID"/>
-              <a:t>Target waktu: 02:30–03:40</a:t>
+              <a:t>Target waktu: 02:40–04:00</a:t>
             </a:r>
           </a:p>
         </p:txBody>
@@ -1359,11 +1498,34 @@
           <a:p>
             <a:r>
               <a:rPr lang="en-ID"/>
-              <a:t>Pipeline saya terdiri dari tiga notebook yang dijalankan berurutan. Notebook pertama membaca sembilan CSV, memvalidasi data, lalu menulis Parquet.
-Notebook kedua menyusun fitur per order dan melakukan eksplorasi model. Detail item dan payment diagregasi lebih dulu supaya join tidak menggandakan nilai.
-Notebook ketiga membentuk graf asal seller dan tujuan customer. Untuk fitur, grain atau unit tiap baris adalah satu order karena label delay juga berada pada order.
-Parquet sudah diimplementasikan, sedangkan warehouse masih berupa rancangan dimensional. NetworkX juga belum menjadi graph database fisik.
-NoSQL dan dashboard masih rencana, dan baru perlu ditambahkan jika kebutuhan pengguna mendukungnya.</a:t>
+              <a:t>Supaya prosesnya mudah diikuti, saya membaginya menjadi tiga notebook. Notebook pertama menangani pembacaan CSV, pemeriksaan data, dan penyimpanan ke Parquet. Notebook kedua menyusun fitur dan model. Notebook ketiga menangani analisis graf.</a:t>
+            </a:r>
+          </a:p>
+          <a:p>
+            <a:endParaRPr lang="en-ID"/>
+          </a:p>
+          <a:p>
+            <a:r>
+              <a:rPr lang="en-ID"/>
+              <a:t>Bagian pentingnya ada pada cara menggabungkan tabel. Satu order bisa mempunyai beberapa item dan beberapa catatan pembayaran. Kalau langsung digabung, nilai yang sama bisa muncul berulang dan totalnya menjadi terlalu besar.</a:t>
+            </a:r>
+          </a:p>
+          <a:p>
+            <a:endParaRPr lang="en-ID"/>
+          </a:p>
+          <a:p>
+            <a:r>
+              <a:rPr lang="en-ID"/>
+              <a:t>Karena itu, detail item dan payment saya ringkas lebih dulu per order. Setelah itu baru saya lakukan join. Hasil fitur akhirnya mempunyai satu baris untuk satu order. Itu yang dimaksud dengan grain order.</a:t>
+            </a:r>
+          </a:p>
+          <a:p>
+            <a:endParaRPr lang="en-ID"/>
+          </a:p>
+          <a:p>
+            <a:r>
+              <a:rPr lang="en-ID"/>
+              <a:t>Parquet sudah berjalan. Warehouse masih berupa rancangan, sementara server NoSQL, graph database fisik, dan dashboard belum saya bangun. NetworkX yang saya gunakan saat ini adalah library graf dalam memori.</a:t>
             </a:r>
           </a:p>
           <a:p>
@@ -1393,7 +1555,7 @@
           <a:p>
             <a:r>
               <a:rPr lang="en-ID"/>
-              <a:t>Target waktu: 03:40–04:40</a:t>
+              <a:t>Target waktu: 04:00–05:00</a:t>
             </a:r>
           </a:p>
         </p:txBody>
@@ -1480,11 +1642,34 @@
           <a:p>
             <a:r>
               <a:rPr lang="en-ID"/>
-              <a:t>Pada bagian ingestion, pemeriksaan demo yang saya jalankan menghasilkan PASS untuk sembilan tabel. Status round-trip pada ringkasan semuanya benar.
-Total ukuran CSV sekitar 120,341 MiB, sedangkan Parquet sekitar 54,236 MiB. Jadi, penghematan storage keseluruhannya 54,93 persen.
-Ini ukuran penyimpanan, belum bukti proses kueri lebih cepat. Saya tetap mempertahankan raw untuk audit.
-Data juga diperiksa dari sisi tipe, ID dan key, jumlah baris, serta profil nilai kosong. Teks review yang kosong dan duplikasi geolocation saya profilkan, bukan langsung hapus dari raw.
-Demo ini memeriksa ringkasan hasil tersimpan. Validasi pembacaan dan konversi penuh sudah dilakukan sebelumnya melalui notebook pertama.</a:t>
+              <a:t>Sekarang masuk ke hasil ingestion. Dari pemeriksaan yang sudah saya jalankan, sembilan tabel menghasilkan PASS. Pada ringkasan, status round-trip semuanya True. Artinya, hasil pengecekan yang dicatat notebook, termasuk jumlah baris dan profil nilai kosong setelah proses baca-tulis, sudah sesuai.</a:t>
+            </a:r>
+          </a:p>
+          <a:p>
+            <a:endParaRPr lang="en-ID"/>
+          </a:p>
+          <a:p>
+            <a:r>
+              <a:rPr lang="en-ID"/>
+              <a:t>Ukuran seluruh CSV sekitar 120,34 MiB. Setelah menjadi Parquet, ukurannya sekitar 54,24 MiB. Jadi, penghematan storage mencapai 54,93 persen. Ini penghematan ruang penyimpanan; kecepatan kueri belum saya ukur.</a:t>
+            </a:r>
+          </a:p>
+          <a:p>
+            <a:endParaRPr lang="en-ID"/>
+          </a:p>
+          <a:p>
+            <a:r>
+              <a:rPr lang="en-ID"/>
+              <a:t>Data raw tetap saya simpan agar sumber awal bisa diperiksa lagi. Nilai kosong pada review dan duplikasi geolocation saya catat dalam profil kualitas data.</a:t>
+            </a:r>
+          </a:p>
+          <a:p>
+            <a:endParaRPr lang="en-ID"/>
+          </a:p>
+          <a:p>
+            <a:r>
+              <a:rPr lang="en-ID"/>
+              <a:t>Perlu dibedakan juga: demo membaca ringkasan hasil tersimpan. Pemeriksaan pembacaan dan konversi lengkap sudah dilakukan lewat notebook pertama sebelumnya.</a:t>
             </a:r>
           </a:p>
           <a:p>
@@ -1514,7 +1699,7 @@
           <a:p>
             <a:r>
               <a:rPr lang="en-ID"/>
-              <a:t>Target waktu: 04:40–05:40</a:t>
+              <a:t>Target waktu: 05:00–05:50</a:t>
             </a:r>
           </a:p>
         </p:txBody>
@@ -1601,10 +1786,34 @@
           <a:p>
             <a:r>
               <a:rPr lang="en-ID"/>
-              <a:t>Selain proses analitik, saya juga mempertimbangkan tata kelola. Praktik yang sudah berjalan adalah mempertahankan raw untuk audit dan menyimpan ringkasan agregat serta kode di Git.
-Dataset raw, credential, runtime, dan output besar tidak masuk repository. Untuk penggunaan operasional, saya merancang akses sesuai peran, retensi, minimisasi data, dan pemeriksaan informasi pribadi pada teks ulasan.
-Penting juga untuk tidak menganggap ID berbentuk hash otomatis anonim. Kontrol operasional ini masih perlu diimplementasikan dan diuji.
-Jadi, saya membedakan praktik prototipe yang sudah berjalan dengan rancangan perlindungan data untuk tahap berikutnya.</a:t>
+              <a:t>Selain menghasilkan analisis, saya juga perlu memastikan data dikelola dengan jelas. Karena itu, raw tetap tersedia untuk audit, sedangkan yang masuk GitHub adalah kode, laporan, dan ringkasan agregat. Dataset raw, credential, serta runtime tidak ikut dipublikasikan.</a:t>
+            </a:r>
+          </a:p>
+          <a:p>
+            <a:endParaRPr lang="en-ID"/>
+          </a:p>
+          <a:p>
+            <a:r>
+              <a:rPr lang="en-ID"/>
+              <a:t>Untuk penggunaan operasional, saya merancang akses sesuai peran, batas penyimpanan data, dan pemeriksaan informasi pribadi pada teks ulasan. Misalnya, tim yang hanya membutuhkan ringkasan rute tidak harus mendapat akses ke seluruh teks review.</a:t>
+            </a:r>
+          </a:p>
+          <a:p>
+            <a:endParaRPr lang="en-ID"/>
+          </a:p>
+          <a:p>
+            <a:r>
+              <a:rPr lang="en-ID"/>
+              <a:t>ID yang terlihat seperti hash juga tidak otomatis membuat seluruh dataset anonim. Informasi pribadi masih mungkin muncul pada teks.</a:t>
+            </a:r>
+          </a:p>
+          <a:p>
+            <a:endParaRPr lang="en-ID"/>
+          </a:p>
+          <a:p>
+            <a:r>
+              <a:rPr lang="en-ID"/>
+              <a:t>Jadi, ada praktik yang sudah berjalan di prototipe dan ada kontrol yang masih perlu diterapkan. Saya belum menganggap prototipe ini membuktikan kepatuhan operasional.</a:t>
             </a:r>
           </a:p>
           <a:p>
@@ -1634,7 +1843,7 @@
           <a:p>
             <a:r>
               <a:rPr lang="en-ID"/>
-              <a:t>Target waktu: 05:40–06:20</a:t>
+              <a:t>Target waktu: 05:50–06:35</a:t>
             </a:r>
           </a:p>
         </p:txBody>
@@ -1721,12 +1930,43 @@
           <a:p>
             <a:r>
               <a:rPr lang="en-ID"/>
-              <a:t>Kelas terlambat jauh lebih sedikit, sehingga accuracy saja bisa menyesatkan. Saya membandingkan Random Forest tanpa bobot dengan model berbobot kelas.
-Kandidat dan ambang dipilih berdasarkan F1 pada validation, lalu dievaluasi pada test. Kandidat tanpa bobot menang, dengan ambang sekitar 0,099536 dan F1 validation sekitar 0,2168.
-Pada partisi test yang sama, ambang 0,5 menghasilkan recall nol. Setelah ambang diturunkan, recall menjadi 45,41 persen.
-Artinya, model menangkap sekitar empat puluh lima persen kasus terlambat dalam test. Tetapi precision hanya 14,47 persen, dan ada 4.186 false positive.
-Jadi, banyak peringatan yang belum tepat. Hasil demo PASS karena pilihan kandidat, jumlah populasi, dan metrik yang dihitung ulang dari confusion matrix konsisten.
-Untuk saat ini model cocok sebagai sinyal peninjauan, dan belum cukup untuk keputusan otomatis.</a:t>
+              <a:t>Untuk model, tantangan utamanya adalah jumlah order terlambat jauh lebih sedikit. Kalau model selalu menjawab tepat waktu, accuracy bisa terlihat tinggi, tetapi tidak membantu menemukan keterlambatan.</a:t>
+            </a:r>
+          </a:p>
+          <a:p>
+            <a:endParaRPr lang="en-ID"/>
+          </a:p>
+          <a:p>
+            <a:r>
+              <a:rPr lang="en-ID"/>
+              <a:t>Saya membandingkan Random Forest tanpa bobot dengan versi yang memberi bobot lebih besar pada kelas terlambat. Data train dipakai untuk belajar, validation untuk memilih kandidat dan ambang, lalu test untuk evaluasi akhir. Jadi, test tidak dipakai untuk menentukan pilihan.</a:t>
+            </a:r>
+          </a:p>
+          <a:p>
+            <a:endParaRPr lang="en-ID"/>
+          </a:p>
+          <a:p>
+            <a:r>
+              <a:rPr lang="en-ID"/>
+              <a:t>Ambang adalah batas skor untuk menandai order berisiko. Berdasarkan F1 validation, kandidat tanpa bobot dipilih dengan ambang sekitar 0,10. Nilai tepatnya ada di slide. F1 menyeimbangkan precision dan recall.</a:t>
+            </a:r>
+          </a:p>
+          <a:p>
+            <a:endParaRPr lang="en-ID"/>
+          </a:p>
+          <a:p>
+            <a:r>
+              <a:rPr lang="en-ID"/>
+              <a:t>Pada test yang sama, recall naik dari nol menjadi 45,41 persen. Artinya, sekitar 45 dari 100 kasus terlambat berhasil ditemukan. Tetapi precision hanya 14,47 persen: dari 100 order yang ditandai, sekitar 14 benar-benar terlambat.</a:t>
+            </a:r>
+          </a:p>
+          <a:p>
+            <a:endParaRPr lang="en-ID"/>
+          </a:p>
+          <a:p>
+            <a:r>
+              <a:rPr lang="en-ID"/>
+              <a:t>Ada 4.186 false positive, yaitu order tepat waktu yang ikut ditandai. Jadi, hasil ini masih untuk peninjauan. Ambang tersebut berasal dari skor model yang belum dikalibrasi sebagai probabilitas.</a:t>
             </a:r>
           </a:p>
           <a:p>
@@ -1756,7 +1996,7 @@
           <a:p>
             <a:r>
               <a:rPr lang="en-ID"/>
-              <a:t>Target waktu: 06:20–07:30</a:t>
+              <a:t>Target waktu: 06:35–07:55</a:t>
             </a:r>
           </a:p>
         </p:txBody>
@@ -1946,7 +2186,7 @@
           <a:p>
             <a:fld id="{478BB0F6-D51F-41BE-8A10-01196C97E34B}" type="datetimeFigureOut">
               <a:rPr lang="en-ID" smtClean="0"/>
-              <a:t>28/09/2026</a:t>
+              <a:t>29/09/2026</a:t>
             </a:fld>
             <a:endParaRPr lang="en-ID"/>
           </a:p>
@@ -2146,7 +2386,7 @@
           <a:p>
             <a:fld id="{478BB0F6-D51F-41BE-8A10-01196C97E34B}" type="datetimeFigureOut">
               <a:rPr lang="en-ID" smtClean="0"/>
-              <a:t>28/09/2026</a:t>
+              <a:t>29/09/2026</a:t>
             </a:fld>
             <a:endParaRPr lang="en-ID"/>
           </a:p>
@@ -2356,7 +2596,7 @@
           <a:p>
             <a:fld id="{478BB0F6-D51F-41BE-8A10-01196C97E34B}" type="datetimeFigureOut">
               <a:rPr lang="en-ID" smtClean="0"/>
-              <a:t>28/09/2026</a:t>
+              <a:t>29/09/2026</a:t>
             </a:fld>
             <a:endParaRPr lang="en-ID"/>
           </a:p>
@@ -2556,7 +2796,7 @@
           <a:p>
             <a:fld id="{478BB0F6-D51F-41BE-8A10-01196C97E34B}" type="datetimeFigureOut">
               <a:rPr lang="en-ID" smtClean="0"/>
-              <a:t>28/09/2026</a:t>
+              <a:t>29/09/2026</a:t>
             </a:fld>
             <a:endParaRPr lang="en-ID"/>
           </a:p>
@@ -2832,7 +3072,7 @@
           <a:p>
             <a:fld id="{478BB0F6-D51F-41BE-8A10-01196C97E34B}" type="datetimeFigureOut">
               <a:rPr lang="en-ID" smtClean="0"/>
-              <a:t>28/09/2026</a:t>
+              <a:t>29/09/2026</a:t>
             </a:fld>
             <a:endParaRPr lang="en-ID"/>
           </a:p>
@@ -3100,7 +3340,7 @@
           <a:p>
             <a:fld id="{478BB0F6-D51F-41BE-8A10-01196C97E34B}" type="datetimeFigureOut">
               <a:rPr lang="en-ID" smtClean="0"/>
-              <a:t>28/09/2026</a:t>
+              <a:t>29/09/2026</a:t>
             </a:fld>
             <a:endParaRPr lang="en-ID"/>
           </a:p>
@@ -3515,7 +3755,7 @@
           <a:p>
             <a:fld id="{478BB0F6-D51F-41BE-8A10-01196C97E34B}" type="datetimeFigureOut">
               <a:rPr lang="en-ID" smtClean="0"/>
-              <a:t>28/09/2026</a:t>
+              <a:t>29/09/2026</a:t>
             </a:fld>
             <a:endParaRPr lang="en-ID"/>
           </a:p>
@@ -3657,7 +3897,7 @@
           <a:p>
             <a:fld id="{478BB0F6-D51F-41BE-8A10-01196C97E34B}" type="datetimeFigureOut">
               <a:rPr lang="en-ID" smtClean="0"/>
-              <a:t>28/09/2026</a:t>
+              <a:t>29/09/2026</a:t>
             </a:fld>
             <a:endParaRPr lang="en-ID"/>
           </a:p>
@@ -3770,7 +4010,7 @@
           <a:p>
             <a:fld id="{478BB0F6-D51F-41BE-8A10-01196C97E34B}" type="datetimeFigureOut">
               <a:rPr lang="en-ID" smtClean="0"/>
-              <a:t>28/09/2026</a:t>
+              <a:t>29/09/2026</a:t>
             </a:fld>
             <a:endParaRPr lang="en-ID"/>
           </a:p>
@@ -4083,7 +4323,7 @@
           <a:p>
             <a:fld id="{478BB0F6-D51F-41BE-8A10-01196C97E34B}" type="datetimeFigureOut">
               <a:rPr lang="en-ID" smtClean="0"/>
-              <a:t>28/09/2026</a:t>
+              <a:t>29/09/2026</a:t>
             </a:fld>
             <a:endParaRPr lang="en-ID"/>
           </a:p>
@@ -4372,7 +4612,7 @@
           <a:p>
             <a:fld id="{478BB0F6-D51F-41BE-8A10-01196C97E34B}" type="datetimeFigureOut">
               <a:rPr lang="en-ID" smtClean="0"/>
-              <a:t>28/09/2026</a:t>
+              <a:t>29/09/2026</a:t>
             </a:fld>
             <a:endParaRPr lang="en-ID"/>
           </a:p>
@@ -4615,7 +4855,7 @@
           <a:p>
             <a:fld id="{478BB0F6-D51F-41BE-8A10-01196C97E34B}" type="datetimeFigureOut">
               <a:rPr lang="en-ID" smtClean="0"/>
-              <a:t>28/09/2026</a:t>
+              <a:t>29/09/2026</a:t>
             </a:fld>
             <a:endParaRPr lang="en-ID"/>
           </a:p>

</xml_diff>